<commit_message>
put the university cover page and an APA 7 reference list in the deck
The cover carries every field the submission needs, including a line for the
unlisted recording link. References sit at the end where a marker expects them,
with hanging indents set through the paragraph XML that python-pptx does not
expose.
</commit_message>
<xml_diff>
--- a/reports/PYRANTIS_presentation.pptx
+++ b/reports/PYRANTIS_presentation.pptx
@@ -27,6 +27,8 @@
     <p:sldId id="275" r:id="rId27"/>
     <p:sldId id="276" r:id="rId28"/>
     <p:sldId id="277" r:id="rId29"/>
+    <p:sldId id="278" r:id="rId30"/>
+    <p:sldId id="279" r:id="rId31"/>
   </p:sldIdLst>
   <p:sldSz cx="12191695" cy="6858000" type="screen4x3"/>
   <p:notesSz cx="6858000" cy="9144000"/>
@@ -1504,6 +1506,146 @@
           <a:p>
             <a:r>
               <a:t>Harsh closes. Land on the use, not the metric.</a:t>
+            </a:r>
+          </a:p>
+        </p:txBody>
+      </p:sp>
+      <p:sp>
+        <p:nvSpPr>
+          <p:cNvPr id="4" name="Slide Number Placeholder 3"/>
+          <p:cNvSpPr>
+            <a:spLocks noGrp="1"/>
+          </p:cNvSpPr>
+          <p:nvPr>
+            <p:ph type="sldNum" idx="5" sz="quarter"/>
+          </p:nvPr>
+        </p:nvSpPr>
+        <p:spPr/>
+      </p:sp>
+    </p:spTree>
+  </p:cSld>
+  <p:clrMapOvr>
+    <a:masterClrMapping/>
+  </p:clrMapOvr>
+</p:notes>
+</file>
+
+<file path=ppt/notesSlides/notesSlide23.xml><?xml version="1.0" encoding="utf-8"?>
+<p:notes xmlns:a="http://schemas.openxmlformats.org/drawingml/2006/main" xmlns:p="http://schemas.openxmlformats.org/presentationml/2006/main" xmlns:r="http://schemas.openxmlformats.org/officeDocument/2006/relationships">
+  <p:cSld>
+    <p:spTree>
+      <p:nvGrpSpPr>
+        <p:cNvPr id="1" name=""/>
+        <p:cNvGrpSpPr/>
+        <p:nvPr/>
+      </p:nvGrpSpPr>
+      <p:grpSpPr>
+        <a:xfrm>
+          <a:off x="0" y="0"/>
+          <a:ext cx="0" cy="0"/>
+          <a:chOff x="0" y="0"/>
+          <a:chExt cx="0" cy="0"/>
+        </a:xfrm>
+      </p:grpSpPr>
+      <p:sp>
+        <p:nvSpPr>
+          <p:cNvPr id="2" name="Slide Image Placeholder 1"/>
+          <p:cNvSpPr>
+            <a:spLocks noGrp="1"/>
+          </p:cNvSpPr>
+          <p:nvPr>
+            <p:ph type="sldImg" idx="2"/>
+          </p:nvPr>
+        </p:nvSpPr>
+        <p:spPr/>
+      </p:sp>
+      <p:sp>
+        <p:nvSpPr>
+          <p:cNvPr id="3" name="Notes Placeholder 2"/>
+          <p:cNvSpPr>
+            <a:spLocks noGrp="1"/>
+          </p:cNvSpPr>
+          <p:nvPr>
+            <p:ph type="body" idx="3" sz="quarter"/>
+          </p:nvPr>
+        </p:nvSpPr>
+        <p:spPr/>
+        <p:txBody>
+          <a:bodyPr/>
+          <a:lstStyle/>
+          <a:p>
+            <a:r>
+              <a:t>Reference slide. Nothing to say -- leave it up during questions.</a:t>
+            </a:r>
+          </a:p>
+        </p:txBody>
+      </p:sp>
+      <p:sp>
+        <p:nvSpPr>
+          <p:cNvPr id="4" name="Slide Number Placeholder 3"/>
+          <p:cNvSpPr>
+            <a:spLocks noGrp="1"/>
+          </p:cNvSpPr>
+          <p:nvPr>
+            <p:ph type="sldNum" idx="5" sz="quarter"/>
+          </p:nvPr>
+        </p:nvSpPr>
+        <p:spPr/>
+      </p:sp>
+    </p:spTree>
+  </p:cSld>
+  <p:clrMapOvr>
+    <a:masterClrMapping/>
+  </p:clrMapOvr>
+</p:notes>
+</file>
+
+<file path=ppt/notesSlides/notesSlide24.xml><?xml version="1.0" encoding="utf-8"?>
+<p:notes xmlns:a="http://schemas.openxmlformats.org/drawingml/2006/main" xmlns:p="http://schemas.openxmlformats.org/presentationml/2006/main" xmlns:r="http://schemas.openxmlformats.org/officeDocument/2006/relationships">
+  <p:cSld>
+    <p:spTree>
+      <p:nvGrpSpPr>
+        <p:cNvPr id="1" name=""/>
+        <p:cNvGrpSpPr/>
+        <p:nvPr/>
+      </p:nvGrpSpPr>
+      <p:grpSpPr>
+        <a:xfrm>
+          <a:off x="0" y="0"/>
+          <a:ext cx="0" cy="0"/>
+          <a:chOff x="0" y="0"/>
+          <a:chExt cx="0" cy="0"/>
+        </a:xfrm>
+      </p:grpSpPr>
+      <p:sp>
+        <p:nvSpPr>
+          <p:cNvPr id="2" name="Slide Image Placeholder 1"/>
+          <p:cNvSpPr>
+            <a:spLocks noGrp="1"/>
+          </p:cNvSpPr>
+          <p:nvPr>
+            <p:ph type="sldImg" idx="2"/>
+          </p:nvPr>
+        </p:nvSpPr>
+        <p:spPr/>
+      </p:sp>
+      <p:sp>
+        <p:nvSpPr>
+          <p:cNvPr id="3" name="Notes Placeholder 2"/>
+          <p:cNvSpPr>
+            <a:spLocks noGrp="1"/>
+          </p:cNvSpPr>
+          <p:nvPr>
+            <p:ph type="body" idx="3" sz="quarter"/>
+          </p:nvPr>
+        </p:nvSpPr>
+        <p:spPr/>
+        <p:txBody>
+          <a:bodyPr/>
+          <a:lstStyle/>
+          <a:p>
+            <a:r>
+              <a:t>Reference slide. Nothing to say -- leave it up during questions.</a:t>
             </a:r>
           </a:p>
         </p:txBody>
@@ -5009,14 +5151,56 @@
       <p:grpSpPr/>
       <p:sp>
         <p:nvSpPr>
-          <p:cNvPr id="2" name="Rounded Rectangle 1"/>
+          <p:cNvPr id="2" name="TextBox 1"/>
+          <p:cNvSpPr txBox="1"/>
+          <p:nvPr/>
+        </p:nvSpPr>
+        <p:spPr>
+          <a:xfrm>
+            <a:off x="822960" y="713232"/>
+            <a:ext cx="10515600" cy="274320"/>
+          </a:xfrm>
+          <a:prstGeom prst="rect">
+            <a:avLst/>
+          </a:prstGeom>
+          <a:noFill/>
+        </p:spPr>
+        <p:txBody>
+          <a:bodyPr wrap="square" anchor="t" lIns="0" rIns="0" tIns="0" bIns="0">
+            <a:spAutoFit/>
+          </a:bodyPr>
+          <a:lstStyle/>
+          <a:p>
+            <a:pPr algn="l">
+              <a:lnSpc>
+                <a:spcPct val="100000"/>
+              </a:lnSpc>
+              <a:spcAft>
+                <a:spcPts val="0"/>
+              </a:spcAft>
+            </a:pPr>
+            <a:r>
+              <a:rPr sz="1150" b="1" i="0">
+                <a:solidFill>
+                  <a:srgbClr val="B9CAD2"/>
+                </a:solidFill>
+                <a:latin typeface="Calibri"/>
+              </a:rPr>
+              <a:t>CHARLES DARWIN UNIVERSITY</a:t>
+            </a:r>
+          </a:p>
+        </p:txBody>
+      </p:sp>
+      <p:sp>
+        <p:nvSpPr>
+          <p:cNvPr id="3" name="Rounded Rectangle 2"/>
           <p:cNvSpPr/>
           <p:nvPr/>
         </p:nvSpPr>
         <p:spPr>
           <a:xfrm>
-            <a:off x="822960" y="1572768"/>
-            <a:ext cx="201168" cy="201168"/>
+            <a:off x="822960" y="1389888"/>
+            <a:ext cx="182880" cy="182880"/>
           </a:xfrm>
           <a:prstGeom prst="roundRect">
             <a:avLst>
@@ -5053,14 +5237,14 @@
       </p:sp>
       <p:sp>
         <p:nvSpPr>
-          <p:cNvPr id="3" name="Rounded Rectangle 2"/>
+          <p:cNvPr id="4" name="Rounded Rectangle 3"/>
           <p:cNvSpPr/>
           <p:nvPr/>
         </p:nvSpPr>
         <p:spPr>
           <a:xfrm>
-            <a:off x="1115568" y="1572768"/>
-            <a:ext cx="201168" cy="201168"/>
+            <a:off x="1088136" y="1389888"/>
+            <a:ext cx="182880" cy="182880"/>
           </a:xfrm>
           <a:prstGeom prst="roundRect">
             <a:avLst>
@@ -5097,14 +5281,14 @@
       </p:sp>
       <p:sp>
         <p:nvSpPr>
-          <p:cNvPr id="4" name="Rounded Rectangle 3"/>
+          <p:cNvPr id="5" name="Rounded Rectangle 4"/>
           <p:cNvSpPr/>
           <p:nvPr/>
         </p:nvSpPr>
         <p:spPr>
           <a:xfrm>
-            <a:off x="1408176" y="1572768"/>
-            <a:ext cx="201168" cy="201168"/>
+            <a:off x="1353312" y="1389888"/>
+            <a:ext cx="182880" cy="182880"/>
           </a:xfrm>
           <a:prstGeom prst="roundRect">
             <a:avLst>
@@ -5141,14 +5325,14 @@
       </p:sp>
       <p:sp>
         <p:nvSpPr>
-          <p:cNvPr id="5" name="TextBox 4"/>
-          <p:cNvSpPr txBox="1"/>
-          <p:nvPr/>
-        </p:nvSpPr>
-        <p:spPr>
-          <a:xfrm>
-            <a:off x="822960" y="2103120"/>
-            <a:ext cx="10515600" cy="1097280"/>
+          <p:cNvPr id="6" name="TextBox 5"/>
+          <p:cNvSpPr txBox="1"/>
+          <p:nvPr/>
+        </p:nvSpPr>
+        <p:spPr>
+          <a:xfrm>
+            <a:off x="822960" y="1847088"/>
+            <a:ext cx="10515600" cy="1005840"/>
           </a:xfrm>
           <a:prstGeom prst="rect">
             <a:avLst/>
@@ -5170,7 +5354,7 @@
               </a:spcAft>
             </a:pPr>
             <a:r>
-              <a:rPr sz="6200" b="1" i="0">
+              <a:rPr sz="5600" b="1" i="0">
                 <a:solidFill>
                   <a:srgbClr val="FFFFFF"/>
                 </a:solidFill>
@@ -5183,14 +5367,14 @@
       </p:sp>
       <p:sp>
         <p:nvSpPr>
-          <p:cNvPr id="6" name="TextBox 5"/>
-          <p:cNvSpPr txBox="1"/>
-          <p:nvPr/>
-        </p:nvSpPr>
-        <p:spPr>
-          <a:xfrm>
-            <a:off x="822960" y="3054096"/>
-            <a:ext cx="8778240" cy="731520"/>
+          <p:cNvPr id="7" name="TextBox 6"/>
+          <p:cNvSpPr txBox="1"/>
+          <p:nvPr/>
+        </p:nvSpPr>
+        <p:spPr>
+          <a:xfrm>
+            <a:off x="822960" y="2724912"/>
+            <a:ext cx="8778240" cy="640080"/>
           </a:xfrm>
           <a:prstGeom prst="rect">
             <a:avLst/>
@@ -5212,7 +5396,7 @@
               </a:spcAft>
             </a:pPr>
             <a:r>
-              <a:rPr sz="2500" b="0" i="0">
+              <a:rPr sz="2200" b="0" i="0">
                 <a:solidFill>
                   <a:srgbClr val="B9CAD2"/>
                 </a:solidFill>
@@ -5225,117 +5409,224 @@
       </p:sp>
       <p:sp>
         <p:nvSpPr>
-          <p:cNvPr id="7" name="TextBox 6"/>
+          <p:cNvPr id="8" name="TextBox 7"/>
+          <p:cNvSpPr txBox="1"/>
+          <p:nvPr/>
+        </p:nvSpPr>
+        <p:spPr>
+          <a:xfrm>
+            <a:off x="822960" y="3401568"/>
+            <a:ext cx="8961120" cy="365760"/>
+          </a:xfrm>
+          <a:prstGeom prst="rect">
+            <a:avLst/>
+          </a:prstGeom>
+          <a:noFill/>
+        </p:spPr>
+        <p:txBody>
+          <a:bodyPr wrap="square" anchor="t" lIns="0" rIns="0" tIns="0" bIns="0">
+            <a:spAutoFit/>
+          </a:bodyPr>
+          <a:lstStyle/>
+          <a:p>
+            <a:pPr algn="l">
+              <a:lnSpc>
+                <a:spcPct val="140000"/>
+              </a:lnSpc>
+              <a:spcAft>
+                <a:spcPts val="0"/>
+              </a:spcAft>
+            </a:pPr>
+            <a:r>
+              <a:rPr sz="1350" b="0" i="0">
+                <a:solidFill>
+                  <a:srgbClr val="B9CAD2"/>
+                </a:solidFill>
+                <a:latin typeface="Calibri"/>
+              </a:rPr>
+              <a:t>Multi-class classification of 46,445 map squares across 26 fire years, and a forecast for 2026.</a:t>
+            </a:r>
+          </a:p>
+        </p:txBody>
+      </p:sp>
+      <p:sp>
+        <p:nvSpPr>
+          <p:cNvPr id="9" name="TextBox 8"/>
           <p:cNvSpPr txBox="1"/>
           <p:nvPr/>
         </p:nvSpPr>
         <p:spPr>
           <a:xfrm>
             <a:off x="822960" y="4133087"/>
-            <a:ext cx="8961120" cy="914400"/>
-          </a:xfrm>
-          <a:prstGeom prst="rect">
-            <a:avLst/>
-          </a:prstGeom>
-          <a:noFill/>
-        </p:spPr>
-        <p:txBody>
-          <a:bodyPr wrap="square" anchor="t" lIns="0" rIns="0" tIns="0" bIns="0">
-            <a:spAutoFit/>
-          </a:bodyPr>
-          <a:lstStyle/>
-          <a:p>
-            <a:pPr algn="l">
-              <a:lnSpc>
-                <a:spcPct val="145000"/>
-              </a:lnSpc>
-              <a:spcAft>
-                <a:spcPts val="0"/>
-              </a:spcAft>
-            </a:pPr>
-            <a:r>
-              <a:rPr sz="1450" b="0" i="0">
+            <a:ext cx="1371600" cy="274320"/>
+          </a:xfrm>
+          <a:prstGeom prst="rect">
+            <a:avLst/>
+          </a:prstGeom>
+          <a:noFill/>
+        </p:spPr>
+        <p:txBody>
+          <a:bodyPr wrap="square" anchor="t" lIns="0" rIns="0" tIns="0" bIns="0">
+            <a:spAutoFit/>
+          </a:bodyPr>
+          <a:lstStyle/>
+          <a:p>
+            <a:pPr algn="l">
+              <a:lnSpc>
+                <a:spcPct val="125000"/>
+              </a:lnSpc>
+              <a:spcAft>
+                <a:spcPts val="0"/>
+              </a:spcAft>
+            </a:pPr>
+            <a:r>
+              <a:rPr sz="1050" b="0" i="0">
                 <a:solidFill>
                   <a:srgbClr val="B9CAD2"/>
                 </a:solidFill>
                 <a:latin typeface="Calibri"/>
               </a:rPr>
-              <a:t>Multi-class classification of 46,445 map squares across 26 fire years, and a forecast for 2026.</a:t>
-            </a:r>
-          </a:p>
-        </p:txBody>
-      </p:sp>
-      <p:sp>
-        <p:nvSpPr>
-          <p:cNvPr id="8" name="TextBox 7"/>
-          <p:cNvSpPr txBox="1"/>
-          <p:nvPr/>
-        </p:nvSpPr>
-        <p:spPr>
-          <a:xfrm>
-            <a:off x="822960" y="5138928"/>
-            <a:ext cx="10515600" cy="1005840"/>
-          </a:xfrm>
-          <a:prstGeom prst="rect">
-            <a:avLst/>
-          </a:prstGeom>
-          <a:noFill/>
-        </p:spPr>
-        <p:txBody>
-          <a:bodyPr wrap="square" anchor="t" lIns="0" rIns="0" tIns="0" bIns="0">
-            <a:spAutoFit/>
-          </a:bodyPr>
-          <a:lstStyle/>
-          <a:p>
-            <a:pPr algn="l">
-              <a:lnSpc>
-                <a:spcPct val="160000"/>
-              </a:lnSpc>
-              <a:spcAft>
-                <a:spcPts val="0"/>
-              </a:spcAft>
-            </a:pPr>
-            <a:r>
-              <a:rPr sz="1200" b="0" i="0">
+              <a:t>Unit</a:t>
+            </a:r>
+          </a:p>
+        </p:txBody>
+      </p:sp>
+      <p:sp>
+        <p:nvSpPr>
+          <p:cNvPr id="10" name="TextBox 9"/>
+          <p:cNvSpPr txBox="1"/>
+          <p:nvPr/>
+        </p:nvSpPr>
+        <p:spPr>
+          <a:xfrm>
+            <a:off x="2331720" y="4133087"/>
+            <a:ext cx="4572000" cy="274320"/>
+          </a:xfrm>
+          <a:prstGeom prst="rect">
+            <a:avLst/>
+          </a:prstGeom>
+          <a:noFill/>
+        </p:spPr>
+        <p:txBody>
+          <a:bodyPr wrap="square" anchor="t" lIns="0" rIns="0" tIns="0" bIns="0">
+            <a:spAutoFit/>
+          </a:bodyPr>
+          <a:lstStyle/>
+          <a:p>
+            <a:pPr algn="l">
+              <a:lnSpc>
+                <a:spcPct val="125000"/>
+              </a:lnSpc>
+              <a:spcAft>
+                <a:spcPts val="0"/>
+              </a:spcAft>
+            </a:pPr>
+            <a:r>
+              <a:rPr sz="1150" b="1" i="0">
+                <a:solidFill>
+                  <a:srgbClr val="FFFFFF"/>
+                </a:solidFill>
+                <a:latin typeface="Calibri"/>
+              </a:rPr>
+              <a:t>Machine Learning, Artificial Intelligence and Algorithms</a:t>
+            </a:r>
+          </a:p>
+        </p:txBody>
+      </p:sp>
+      <p:sp>
+        <p:nvSpPr>
+          <p:cNvPr id="11" name="TextBox 10"/>
+          <p:cNvSpPr txBox="1"/>
+          <p:nvPr/>
+        </p:nvSpPr>
+        <p:spPr>
+          <a:xfrm>
+            <a:off x="822960" y="4535424"/>
+            <a:ext cx="1371600" cy="274320"/>
+          </a:xfrm>
+          <a:prstGeom prst="rect">
+            <a:avLst/>
+          </a:prstGeom>
+          <a:noFill/>
+        </p:spPr>
+        <p:txBody>
+          <a:bodyPr wrap="square" anchor="t" lIns="0" rIns="0" tIns="0" bIns="0">
+            <a:spAutoFit/>
+          </a:bodyPr>
+          <a:lstStyle/>
+          <a:p>
+            <a:pPr algn="l">
+              <a:lnSpc>
+                <a:spcPct val="125000"/>
+              </a:lnSpc>
+              <a:spcAft>
+                <a:spcPts val="0"/>
+              </a:spcAft>
+            </a:pPr>
+            <a:r>
+              <a:rPr sz="1050" b="0" i="0">
                 <a:solidFill>
                   <a:srgbClr val="B9CAD2"/>
                 </a:solidFill>
                 <a:latin typeface="Calibri"/>
               </a:rPr>
-              <a:t>PRT565 Machine Learning, Artificial Intelligence and Algorithms  ·  Assessment 3  ·  Group 85</a:t>
-            </a:r>
-          </a:p>
-          <a:p>
-            <a:pPr algn="l">
-              <a:lnSpc>
-                <a:spcPct val="160000"/>
-              </a:lnSpc>
-              <a:spcAft>
-                <a:spcPts val="0"/>
-              </a:spcAft>
-            </a:pPr>
-            <a:r>
-              <a:rPr sz="1250" b="1" i="0">
+              <a:t>Unit code</a:t>
+            </a:r>
+          </a:p>
+        </p:txBody>
+      </p:sp>
+      <p:sp>
+        <p:nvSpPr>
+          <p:cNvPr id="12" name="TextBox 11"/>
+          <p:cNvSpPr txBox="1"/>
+          <p:nvPr/>
+        </p:nvSpPr>
+        <p:spPr>
+          <a:xfrm>
+            <a:off x="2331720" y="4535424"/>
+            <a:ext cx="4572000" cy="274320"/>
+          </a:xfrm>
+          <a:prstGeom prst="rect">
+            <a:avLst/>
+          </a:prstGeom>
+          <a:noFill/>
+        </p:spPr>
+        <p:txBody>
+          <a:bodyPr wrap="square" anchor="t" lIns="0" rIns="0" tIns="0" bIns="0">
+            <a:spAutoFit/>
+          </a:bodyPr>
+          <a:lstStyle/>
+          <a:p>
+            <a:pPr algn="l">
+              <a:lnSpc>
+                <a:spcPct val="125000"/>
+              </a:lnSpc>
+              <a:spcAft>
+                <a:spcPts val="0"/>
+              </a:spcAft>
+            </a:pPr>
+            <a:r>
+              <a:rPr sz="1150" b="1" i="0">
                 <a:solidFill>
                   <a:srgbClr val="FFFFFF"/>
                 </a:solidFill>
                 <a:latin typeface="Calibri"/>
               </a:rPr>
-              <a:t>Harsh Rastogi 386401   ·   Saira Zafar 407193   ·   Tharushi Wimalachandra 386594</a:t>
-            </a:r>
-          </a:p>
-        </p:txBody>
-      </p:sp>
-      <p:sp>
-        <p:nvSpPr>
-          <p:cNvPr id="9" name="TextBox 8"/>
-          <p:cNvSpPr txBox="1"/>
-          <p:nvPr/>
-        </p:nvSpPr>
-        <p:spPr>
-          <a:xfrm>
-            <a:off x="822960" y="6327648"/>
-            <a:ext cx="5486400" cy="274320"/>
+              <a:t>PRT565</a:t>
+            </a:r>
+          </a:p>
+        </p:txBody>
+      </p:sp>
+      <p:sp>
+        <p:nvSpPr>
+          <p:cNvPr id="13" name="TextBox 12"/>
+          <p:cNvSpPr txBox="1"/>
+          <p:nvPr/>
+        </p:nvSpPr>
+        <p:spPr>
+          <a:xfrm>
+            <a:off x="822960" y="4937760"/>
+            <a:ext cx="1371600" cy="274320"/>
           </a:xfrm>
           <a:prstGeom prst="rect">
             <a:avLst/>
@@ -5359,7 +5650,597 @@
             <a:r>
               <a:rPr sz="1050" b="0" i="0">
                 <a:solidFill>
+                  <a:srgbClr val="B9CAD2"/>
+                </a:solidFill>
+                <a:latin typeface="Calibri"/>
+              </a:rPr>
+              <a:t>Assessment</a:t>
+            </a:r>
+          </a:p>
+        </p:txBody>
+      </p:sp>
+      <p:sp>
+        <p:nvSpPr>
+          <p:cNvPr id="14" name="TextBox 13"/>
+          <p:cNvSpPr txBox="1"/>
+          <p:nvPr/>
+        </p:nvSpPr>
+        <p:spPr>
+          <a:xfrm>
+            <a:off x="2331720" y="4937760"/>
+            <a:ext cx="4572000" cy="274320"/>
+          </a:xfrm>
+          <a:prstGeom prst="rect">
+            <a:avLst/>
+          </a:prstGeom>
+          <a:noFill/>
+        </p:spPr>
+        <p:txBody>
+          <a:bodyPr wrap="square" anchor="t" lIns="0" rIns="0" tIns="0" bIns="0">
+            <a:spAutoFit/>
+          </a:bodyPr>
+          <a:lstStyle/>
+          <a:p>
+            <a:pPr algn="l">
+              <a:lnSpc>
+                <a:spcPct val="125000"/>
+              </a:lnSpc>
+              <a:spcAft>
+                <a:spcPts val="0"/>
+              </a:spcAft>
+            </a:pPr>
+            <a:r>
+              <a:rPr sz="1150" b="1" i="0">
+                <a:solidFill>
+                  <a:srgbClr val="FFFFFF"/>
+                </a:solidFill>
+                <a:latin typeface="Calibri"/>
+              </a:rPr>
+              <a:t>Assessment 3 — Presentation</a:t>
+            </a:r>
+          </a:p>
+        </p:txBody>
+      </p:sp>
+      <p:sp>
+        <p:nvSpPr>
+          <p:cNvPr id="15" name="TextBox 14"/>
+          <p:cNvSpPr txBox="1"/>
+          <p:nvPr/>
+        </p:nvSpPr>
+        <p:spPr>
+          <a:xfrm>
+            <a:off x="822960" y="5340096"/>
+            <a:ext cx="1371600" cy="274320"/>
+          </a:xfrm>
+          <a:prstGeom prst="rect">
+            <a:avLst/>
+          </a:prstGeom>
+          <a:noFill/>
+        </p:spPr>
+        <p:txBody>
+          <a:bodyPr wrap="square" anchor="t" lIns="0" rIns="0" tIns="0" bIns="0">
+            <a:spAutoFit/>
+          </a:bodyPr>
+          <a:lstStyle/>
+          <a:p>
+            <a:pPr algn="l">
+              <a:lnSpc>
+                <a:spcPct val="125000"/>
+              </a:lnSpc>
+              <a:spcAft>
+                <a:spcPts val="0"/>
+              </a:spcAft>
+            </a:pPr>
+            <a:r>
+              <a:rPr sz="1050" b="0" i="0">
+                <a:solidFill>
+                  <a:srgbClr val="B9CAD2"/>
+                </a:solidFill>
+                <a:latin typeface="Calibri"/>
+              </a:rPr>
+              <a:t>Group</a:t>
+            </a:r>
+          </a:p>
+        </p:txBody>
+      </p:sp>
+      <p:sp>
+        <p:nvSpPr>
+          <p:cNvPr id="16" name="TextBox 15"/>
+          <p:cNvSpPr txBox="1"/>
+          <p:nvPr/>
+        </p:nvSpPr>
+        <p:spPr>
+          <a:xfrm>
+            <a:off x="2331720" y="5340096"/>
+            <a:ext cx="4572000" cy="274320"/>
+          </a:xfrm>
+          <a:prstGeom prst="rect">
+            <a:avLst/>
+          </a:prstGeom>
+          <a:noFill/>
+        </p:spPr>
+        <p:txBody>
+          <a:bodyPr wrap="square" anchor="t" lIns="0" rIns="0" tIns="0" bIns="0">
+            <a:spAutoFit/>
+          </a:bodyPr>
+          <a:lstStyle/>
+          <a:p>
+            <a:pPr algn="l">
+              <a:lnSpc>
+                <a:spcPct val="125000"/>
+              </a:lnSpc>
+              <a:spcAft>
+                <a:spcPts val="0"/>
+              </a:spcAft>
+            </a:pPr>
+            <a:r>
+              <a:rPr sz="1150" b="1" i="0">
+                <a:solidFill>
+                  <a:srgbClr val="FFFFFF"/>
+                </a:solidFill>
+                <a:latin typeface="Calibri"/>
+              </a:rPr>
+              <a:t>Group 85</a:t>
+            </a:r>
+          </a:p>
+        </p:txBody>
+      </p:sp>
+      <p:sp>
+        <p:nvSpPr>
+          <p:cNvPr id="17" name="TextBox 16"/>
+          <p:cNvSpPr txBox="1"/>
+          <p:nvPr/>
+        </p:nvSpPr>
+        <p:spPr>
+          <a:xfrm>
+            <a:off x="7452360" y="4133087"/>
+            <a:ext cx="3931920" cy="274320"/>
+          </a:xfrm>
+          <a:prstGeom prst="rect">
+            <a:avLst/>
+          </a:prstGeom>
+          <a:noFill/>
+        </p:spPr>
+        <p:txBody>
+          <a:bodyPr wrap="square" anchor="t" lIns="0" rIns="0" tIns="0" bIns="0">
+            <a:spAutoFit/>
+          </a:bodyPr>
+          <a:lstStyle/>
+          <a:p>
+            <a:pPr algn="l">
+              <a:lnSpc>
+                <a:spcPct val="125000"/>
+              </a:lnSpc>
+              <a:spcAft>
+                <a:spcPts val="0"/>
+              </a:spcAft>
+            </a:pPr>
+            <a:r>
+              <a:rPr sz="1050" b="0" i="0">
+                <a:solidFill>
+                  <a:srgbClr val="B9CAD2"/>
+                </a:solidFill>
+                <a:latin typeface="Calibri"/>
+              </a:rPr>
+              <a:t>Team</a:t>
+            </a:r>
+          </a:p>
+        </p:txBody>
+      </p:sp>
+      <p:sp>
+        <p:nvSpPr>
+          <p:cNvPr id="18" name="TextBox 17"/>
+          <p:cNvSpPr txBox="1"/>
+          <p:nvPr/>
+        </p:nvSpPr>
+        <p:spPr>
+          <a:xfrm>
+            <a:off x="7452360" y="4535424"/>
+            <a:ext cx="2926080" cy="274320"/>
+          </a:xfrm>
+          <a:prstGeom prst="rect">
+            <a:avLst/>
+          </a:prstGeom>
+          <a:noFill/>
+        </p:spPr>
+        <p:txBody>
+          <a:bodyPr wrap="square" anchor="t" lIns="0" rIns="0" tIns="0" bIns="0">
+            <a:spAutoFit/>
+          </a:bodyPr>
+          <a:lstStyle/>
+          <a:p>
+            <a:pPr algn="l">
+              <a:lnSpc>
+                <a:spcPct val="125000"/>
+              </a:lnSpc>
+              <a:spcAft>
+                <a:spcPts val="0"/>
+              </a:spcAft>
+            </a:pPr>
+            <a:r>
+              <a:rPr sz="1150" b="1" i="0">
+                <a:solidFill>
+                  <a:srgbClr val="FFFFFF"/>
+                </a:solidFill>
+                <a:latin typeface="Calibri"/>
+              </a:rPr>
+              <a:t>Harsh Rastogi</a:t>
+            </a:r>
+          </a:p>
+        </p:txBody>
+      </p:sp>
+      <p:sp>
+        <p:nvSpPr>
+          <p:cNvPr id="19" name="TextBox 18"/>
+          <p:cNvSpPr txBox="1"/>
+          <p:nvPr/>
+        </p:nvSpPr>
+        <p:spPr>
+          <a:xfrm>
+            <a:off x="10607040" y="4535424"/>
+            <a:ext cx="777240" cy="274320"/>
+          </a:xfrm>
+          <a:prstGeom prst="rect">
+            <a:avLst/>
+          </a:prstGeom>
+          <a:noFill/>
+        </p:spPr>
+        <p:txBody>
+          <a:bodyPr wrap="square" anchor="t" lIns="0" rIns="0" tIns="0" bIns="0">
+            <a:spAutoFit/>
+          </a:bodyPr>
+          <a:lstStyle/>
+          <a:p>
+            <a:pPr algn="r">
+              <a:lnSpc>
+                <a:spcPct val="125000"/>
+              </a:lnSpc>
+              <a:spcAft>
+                <a:spcPts val="0"/>
+              </a:spcAft>
+            </a:pPr>
+            <a:r>
+              <a:rPr sz="1100" b="0" i="0">
+                <a:solidFill>
+                  <a:srgbClr val="B9CAD2"/>
+                </a:solidFill>
+                <a:latin typeface="Calibri"/>
+              </a:rPr>
+              <a:t>386401</a:t>
+            </a:r>
+          </a:p>
+        </p:txBody>
+      </p:sp>
+      <p:sp>
+        <p:nvSpPr>
+          <p:cNvPr id="20" name="TextBox 19"/>
+          <p:cNvSpPr txBox="1"/>
+          <p:nvPr/>
+        </p:nvSpPr>
+        <p:spPr>
+          <a:xfrm>
+            <a:off x="7452360" y="4937760"/>
+            <a:ext cx="2926080" cy="274320"/>
+          </a:xfrm>
+          <a:prstGeom prst="rect">
+            <a:avLst/>
+          </a:prstGeom>
+          <a:noFill/>
+        </p:spPr>
+        <p:txBody>
+          <a:bodyPr wrap="square" anchor="t" lIns="0" rIns="0" tIns="0" bIns="0">
+            <a:spAutoFit/>
+          </a:bodyPr>
+          <a:lstStyle/>
+          <a:p>
+            <a:pPr algn="l">
+              <a:lnSpc>
+                <a:spcPct val="125000"/>
+              </a:lnSpc>
+              <a:spcAft>
+                <a:spcPts val="0"/>
+              </a:spcAft>
+            </a:pPr>
+            <a:r>
+              <a:rPr sz="1150" b="1" i="0">
+                <a:solidFill>
+                  <a:srgbClr val="FFFFFF"/>
+                </a:solidFill>
+                <a:latin typeface="Calibri"/>
+              </a:rPr>
+              <a:t>Saira Zafar</a:t>
+            </a:r>
+          </a:p>
+        </p:txBody>
+      </p:sp>
+      <p:sp>
+        <p:nvSpPr>
+          <p:cNvPr id="21" name="TextBox 20"/>
+          <p:cNvSpPr txBox="1"/>
+          <p:nvPr/>
+        </p:nvSpPr>
+        <p:spPr>
+          <a:xfrm>
+            <a:off x="10607040" y="4937760"/>
+            <a:ext cx="777240" cy="274320"/>
+          </a:xfrm>
+          <a:prstGeom prst="rect">
+            <a:avLst/>
+          </a:prstGeom>
+          <a:noFill/>
+        </p:spPr>
+        <p:txBody>
+          <a:bodyPr wrap="square" anchor="t" lIns="0" rIns="0" tIns="0" bIns="0">
+            <a:spAutoFit/>
+          </a:bodyPr>
+          <a:lstStyle/>
+          <a:p>
+            <a:pPr algn="r">
+              <a:lnSpc>
+                <a:spcPct val="125000"/>
+              </a:lnSpc>
+              <a:spcAft>
+                <a:spcPts val="0"/>
+              </a:spcAft>
+            </a:pPr>
+            <a:r>
+              <a:rPr sz="1100" b="0" i="0">
+                <a:solidFill>
+                  <a:srgbClr val="B9CAD2"/>
+                </a:solidFill>
+                <a:latin typeface="Calibri"/>
+              </a:rPr>
+              <a:t>407193</a:t>
+            </a:r>
+          </a:p>
+        </p:txBody>
+      </p:sp>
+      <p:sp>
+        <p:nvSpPr>
+          <p:cNvPr id="22" name="TextBox 21"/>
+          <p:cNvSpPr txBox="1"/>
+          <p:nvPr/>
+        </p:nvSpPr>
+        <p:spPr>
+          <a:xfrm>
+            <a:off x="7452360" y="5340096"/>
+            <a:ext cx="2926080" cy="274320"/>
+          </a:xfrm>
+          <a:prstGeom prst="rect">
+            <a:avLst/>
+          </a:prstGeom>
+          <a:noFill/>
+        </p:spPr>
+        <p:txBody>
+          <a:bodyPr wrap="square" anchor="t" lIns="0" rIns="0" tIns="0" bIns="0">
+            <a:spAutoFit/>
+          </a:bodyPr>
+          <a:lstStyle/>
+          <a:p>
+            <a:pPr algn="l">
+              <a:lnSpc>
+                <a:spcPct val="125000"/>
+              </a:lnSpc>
+              <a:spcAft>
+                <a:spcPts val="0"/>
+              </a:spcAft>
+            </a:pPr>
+            <a:r>
+              <a:rPr sz="1150" b="1" i="0">
+                <a:solidFill>
+                  <a:srgbClr val="FFFFFF"/>
+                </a:solidFill>
+                <a:latin typeface="Calibri"/>
+              </a:rPr>
+              <a:t>Tharushi Wimalachandra</a:t>
+            </a:r>
+          </a:p>
+        </p:txBody>
+      </p:sp>
+      <p:sp>
+        <p:nvSpPr>
+          <p:cNvPr id="23" name="TextBox 22"/>
+          <p:cNvSpPr txBox="1"/>
+          <p:nvPr/>
+        </p:nvSpPr>
+        <p:spPr>
+          <a:xfrm>
+            <a:off x="10607040" y="5340096"/>
+            <a:ext cx="777240" cy="274320"/>
+          </a:xfrm>
+          <a:prstGeom prst="rect">
+            <a:avLst/>
+          </a:prstGeom>
+          <a:noFill/>
+        </p:spPr>
+        <p:txBody>
+          <a:bodyPr wrap="square" anchor="t" lIns="0" rIns="0" tIns="0" bIns="0">
+            <a:spAutoFit/>
+          </a:bodyPr>
+          <a:lstStyle/>
+          <a:p>
+            <a:pPr algn="r">
+              <a:lnSpc>
+                <a:spcPct val="125000"/>
+              </a:lnSpc>
+              <a:spcAft>
+                <a:spcPts val="0"/>
+              </a:spcAft>
+            </a:pPr>
+            <a:r>
+              <a:rPr sz="1100" b="0" i="0">
+                <a:solidFill>
+                  <a:srgbClr val="B9CAD2"/>
+                </a:solidFill>
+                <a:latin typeface="Calibri"/>
+              </a:rPr>
+              <a:t>386594</a:t>
+            </a:r>
+          </a:p>
+        </p:txBody>
+      </p:sp>
+      <p:sp>
+        <p:nvSpPr>
+          <p:cNvPr id="24" name="Rounded Rectangle 23"/>
+          <p:cNvSpPr/>
+          <p:nvPr/>
+        </p:nvSpPr>
+        <p:spPr>
+          <a:xfrm>
+            <a:off x="822960" y="5742432"/>
+            <a:ext cx="10515600" cy="566928"/>
+          </a:xfrm>
+          <a:prstGeom prst="roundRect">
+            <a:avLst>
+              <a:gd name="adj" fmla="val 6000"/>
+            </a:avLst>
+          </a:prstGeom>
+          <a:solidFill>
+            <a:srgbClr val="173B49"/>
+          </a:solidFill>
+          <a:ln>
+            <a:noFill/>
+          </a:ln>
+          <a:effectLst/>
+        </p:spPr>
+        <p:style>
+          <a:lnRef idx="1">
+            <a:schemeClr val="accent1"/>
+          </a:lnRef>
+          <a:fillRef idx="3">
+            <a:schemeClr val="accent1"/>
+          </a:fillRef>
+          <a:effectRef idx="2">
+            <a:schemeClr val="accent1"/>
+          </a:effectRef>
+          <a:fontRef idx="minor">
+            <a:schemeClr val="lt1"/>
+          </a:fontRef>
+        </p:style>
+        <p:txBody>
+          <a:bodyPr rtlCol="0" anchor="ctr"/>
+          <a:lstStyle/>
+          <a:p/>
+        </p:txBody>
+      </p:sp>
+      <p:sp>
+        <p:nvSpPr>
+          <p:cNvPr id="25" name="TextBox 24"/>
+          <p:cNvSpPr txBox="1"/>
+          <p:nvPr/>
+        </p:nvSpPr>
+        <p:spPr>
+          <a:xfrm>
+            <a:off x="1133856" y="5907024"/>
+            <a:ext cx="2743200" cy="274320"/>
+          </a:xfrm>
+          <a:prstGeom prst="rect">
+            <a:avLst/>
+          </a:prstGeom>
+          <a:noFill/>
+        </p:spPr>
+        <p:txBody>
+          <a:bodyPr wrap="square" anchor="t" lIns="0" rIns="0" tIns="0" bIns="0">
+            <a:spAutoFit/>
+          </a:bodyPr>
+          <a:lstStyle/>
+          <a:p>
+            <a:pPr algn="l">
+              <a:lnSpc>
+                <a:spcPct val="125000"/>
+              </a:lnSpc>
+              <a:spcAft>
+                <a:spcPts val="0"/>
+              </a:spcAft>
+            </a:pPr>
+            <a:r>
+              <a:rPr sz="1050" b="0" i="0">
+                <a:solidFill>
+                  <a:srgbClr val="B9CAD2"/>
+                </a:solidFill>
+                <a:latin typeface="Calibri"/>
+              </a:rPr>
+              <a:t>Recording (unlisted)</a:t>
+            </a:r>
+          </a:p>
+        </p:txBody>
+      </p:sp>
+      <p:sp>
+        <p:nvSpPr>
+          <p:cNvPr id="26" name="TextBox 25"/>
+          <p:cNvSpPr txBox="1"/>
+          <p:nvPr/>
+        </p:nvSpPr>
+        <p:spPr>
+          <a:xfrm>
+            <a:off x="3749039" y="5907024"/>
+            <a:ext cx="4206240" cy="274320"/>
+          </a:xfrm>
+          <a:prstGeom prst="rect">
+            <a:avLst/>
+          </a:prstGeom>
+          <a:noFill/>
+        </p:spPr>
+        <p:txBody>
+          <a:bodyPr wrap="square" anchor="t" lIns="0" rIns="0" tIns="0" bIns="0">
+            <a:spAutoFit/>
+          </a:bodyPr>
+          <a:lstStyle/>
+          <a:p>
+            <a:pPr algn="l">
+              <a:lnSpc>
+                <a:spcPct val="125000"/>
+              </a:lnSpc>
+              <a:spcAft>
+                <a:spcPts val="0"/>
+              </a:spcAft>
+            </a:pPr>
+            <a:r>
+              <a:rPr sz="1100" b="0" i="0">
+                <a:solidFill>
                   <a:srgbClr val="E0835C"/>
+                </a:solidFill>
+                <a:latin typeface="Calibri"/>
+              </a:rPr>
+              <a:t>[ paste the unlisted video link here ]</a:t>
+            </a:r>
+          </a:p>
+        </p:txBody>
+      </p:sp>
+      <p:sp>
+        <p:nvSpPr>
+          <p:cNvPr id="27" name="TextBox 26"/>
+          <p:cNvSpPr txBox="1"/>
+          <p:nvPr/>
+        </p:nvSpPr>
+        <p:spPr>
+          <a:xfrm>
+            <a:off x="8321040" y="5907024"/>
+            <a:ext cx="2743200" cy="274320"/>
+          </a:xfrm>
+          <a:prstGeom prst="rect">
+            <a:avLst/>
+          </a:prstGeom>
+          <a:noFill/>
+        </p:spPr>
+        <p:txBody>
+          <a:bodyPr wrap="square" anchor="t" lIns="0" rIns="0" tIns="0" bIns="0">
+            <a:spAutoFit/>
+          </a:bodyPr>
+          <a:lstStyle/>
+          <a:p>
+            <a:pPr algn="r">
+              <a:lnSpc>
+                <a:spcPct val="125000"/>
+              </a:lnSpc>
+              <a:spcAft>
+                <a:spcPts val="0"/>
+              </a:spcAft>
+            </a:pPr>
+            <a:r>
+              <a:rPr sz="1050" b="0" i="0">
+                <a:solidFill>
+                  <a:srgbClr val="B9CAD2"/>
                 </a:solidFill>
                 <a:latin typeface="Calibri"/>
               </a:rPr>
@@ -13166,6 +14047,790 @@
                 <a:latin typeface="Calibri"/>
               </a:rPr>
               <a:t>22</a:t>
+            </a:r>
+          </a:p>
+        </p:txBody>
+      </p:sp>
+    </p:spTree>
+  </p:cSld>
+  <p:clrMapOvr>
+    <a:masterClrMapping/>
+  </p:clrMapOvr>
+</p:sld>
+</file>
+
+<file path=ppt/slides/slide23.xml><?xml version="1.0" encoding="utf-8"?>
+<p:sld xmlns:a="http://schemas.openxmlformats.org/drawingml/2006/main" xmlns:p="http://schemas.openxmlformats.org/presentationml/2006/main" xmlns:r="http://schemas.openxmlformats.org/officeDocument/2006/relationships">
+  <p:cSld>
+    <p:bg>
+      <p:bgPr>
+        <a:solidFill>
+          <a:srgbClr val="F7F5F2"/>
+        </a:solidFill>
+        <a:effectLst/>
+      </p:bgPr>
+    </p:bg>
+    <p:spTree>
+      <p:nvGrpSpPr>
+        <p:cNvPr id="1" name=""/>
+        <p:cNvGrpSpPr/>
+        <p:nvPr/>
+      </p:nvGrpSpPr>
+      <p:grpSpPr/>
+      <p:sp>
+        <p:nvSpPr>
+          <p:cNvPr id="2" name="TextBox 1"/>
+          <p:cNvSpPr txBox="1"/>
+          <p:nvPr/>
+        </p:nvSpPr>
+        <p:spPr>
+          <a:xfrm>
+            <a:off x="822960" y="310896"/>
+            <a:ext cx="10607040" cy="274320"/>
+          </a:xfrm>
+          <a:prstGeom prst="rect">
+            <a:avLst/>
+          </a:prstGeom>
+          <a:noFill/>
+        </p:spPr>
+        <p:txBody>
+          <a:bodyPr wrap="square" anchor="t" lIns="0" rIns="0" tIns="0" bIns="0">
+            <a:spAutoFit/>
+          </a:bodyPr>
+          <a:lstStyle/>
+          <a:p>
+            <a:pPr algn="l">
+              <a:lnSpc>
+                <a:spcPct val="100000"/>
+              </a:lnSpc>
+              <a:spcAft>
+                <a:spcPts val="0"/>
+              </a:spcAft>
+            </a:pPr>
+            <a:r>
+              <a:rPr sz="1100" b="1" i="0">
+                <a:solidFill>
+                  <a:srgbClr val="C8552F"/>
+                </a:solidFill>
+                <a:latin typeface="Calibri"/>
+              </a:rPr>
+              <a:t>REFERENCES</a:t>
+            </a:r>
+          </a:p>
+        </p:txBody>
+      </p:sp>
+      <p:sp>
+        <p:nvSpPr>
+          <p:cNvPr id="3" name="TextBox 2"/>
+          <p:cNvSpPr txBox="1"/>
+          <p:nvPr/>
+        </p:nvSpPr>
+        <p:spPr>
+          <a:xfrm>
+            <a:off x="822960" y="566928"/>
+            <a:ext cx="10607040" cy="914400"/>
+          </a:xfrm>
+          <a:prstGeom prst="rect">
+            <a:avLst/>
+          </a:prstGeom>
+          <a:noFill/>
+        </p:spPr>
+        <p:txBody>
+          <a:bodyPr wrap="square" anchor="t" lIns="0" rIns="0" tIns="0" bIns="0">
+            <a:spAutoFit/>
+          </a:bodyPr>
+          <a:lstStyle/>
+          <a:p>
+            <a:pPr algn="l">
+              <a:lnSpc>
+                <a:spcPct val="105000"/>
+              </a:lnSpc>
+              <a:spcAft>
+                <a:spcPts val="0"/>
+              </a:spcAft>
+            </a:pPr>
+            <a:r>
+              <a:rPr sz="3400" b="1" i="0">
+                <a:solidFill>
+                  <a:srgbClr val="0F2A35"/>
+                </a:solidFill>
+                <a:latin typeface="Cambria"/>
+              </a:rPr>
+              <a:t>References (1 of 2)</a:t>
+            </a:r>
+          </a:p>
+        </p:txBody>
+      </p:sp>
+      <p:sp>
+        <p:nvSpPr>
+          <p:cNvPr id="4" name="TextBox 3"/>
+          <p:cNvSpPr txBox="1"/>
+          <p:nvPr/>
+        </p:nvSpPr>
+        <p:spPr>
+          <a:xfrm>
+            <a:off x="822960" y="1572768"/>
+            <a:ext cx="10515600" cy="292608"/>
+          </a:xfrm>
+          <a:prstGeom prst="rect">
+            <a:avLst/>
+          </a:prstGeom>
+          <a:noFill/>
+        </p:spPr>
+        <p:txBody>
+          <a:bodyPr wrap="square" anchor="t" lIns="0" rIns="0" tIns="0" bIns="0">
+            <a:spAutoFit/>
+          </a:bodyPr>
+          <a:lstStyle/>
+          <a:p>
+            <a:pPr algn="l">
+              <a:lnSpc>
+                <a:spcPct val="125000"/>
+              </a:lnSpc>
+              <a:spcAft>
+                <a:spcPts val="0"/>
+              </a:spcAft>
+            </a:pPr>
+            <a:r>
+              <a:rPr sz="1150" b="0" i="0">
+                <a:solidFill>
+                  <a:srgbClr val="6B7C85"/>
+                </a:solidFill>
+                <a:latin typeface="Calibri"/>
+              </a:rPr>
+              <a:t>American Psychological Association, 7th edition</a:t>
+            </a:r>
+          </a:p>
+        </p:txBody>
+      </p:sp>
+      <p:sp>
+        <p:nvSpPr>
+          <p:cNvPr id="5" name="TextBox 4"/>
+          <p:cNvSpPr txBox="1"/>
+          <p:nvPr/>
+        </p:nvSpPr>
+        <p:spPr>
+          <a:xfrm>
+            <a:off x="822960" y="2029968"/>
+            <a:ext cx="10515600" cy="4023360"/>
+          </a:xfrm>
+          <a:prstGeom prst="rect">
+            <a:avLst/>
+          </a:prstGeom>
+          <a:noFill/>
+        </p:spPr>
+        <p:txBody>
+          <a:bodyPr wrap="square" anchor="t" lIns="0" rIns="0" tIns="0" bIns="0">
+            <a:spAutoFit/>
+          </a:bodyPr>
+          <a:lstStyle/>
+          <a:p>
+            <a:pPr algn="l" marL="274320" indent="-274320">
+              <a:lnSpc>
+                <a:spcPct val="132000"/>
+              </a:lnSpc>
+              <a:spcAft>
+                <a:spcPts val="1200"/>
+              </a:spcAft>
+            </a:pPr>
+            <a:r>
+              <a:rPr sz="1220" b="0" i="0">
+                <a:solidFill>
+                  <a:srgbClr val="0F2A35"/>
+                </a:solidFill>
+                <a:latin typeface="Calibri"/>
+              </a:rPr>
+              <a:t>Breiman, L. (2001). Random forests. Machine Learning, 45(1), 5–32. https://doi.org/10.1023/A:1010933404324</a:t>
+            </a:r>
+          </a:p>
+          <a:p>
+            <a:pPr algn="l" marL="274320" indent="-274320">
+              <a:lnSpc>
+                <a:spcPct val="132000"/>
+              </a:lnSpc>
+              <a:spcAft>
+                <a:spcPts val="1200"/>
+              </a:spcAft>
+            </a:pPr>
+            <a:r>
+              <a:rPr sz="1220" b="0" i="0">
+                <a:solidFill>
+                  <a:srgbClr val="0F2A35"/>
+                </a:solidFill>
+                <a:latin typeface="Calibri"/>
+              </a:rPr>
+              <a:t>Chollet, F., &amp; others. (2015). Keras [Computer software]. https://keras.io</a:t>
+            </a:r>
+          </a:p>
+          <a:p>
+            <a:pPr algn="l" marL="274320" indent="-274320">
+              <a:lnSpc>
+                <a:spcPct val="132000"/>
+              </a:lnSpc>
+              <a:spcAft>
+                <a:spcPts val="1200"/>
+              </a:spcAft>
+            </a:pPr>
+            <a:r>
+              <a:rPr sz="1220" b="0" i="0">
+                <a:solidFill>
+                  <a:srgbClr val="0F2A35"/>
+                </a:solidFill>
+                <a:latin typeface="Calibri"/>
+              </a:rPr>
+              <a:t>Didan, K. (2021). MODIS/Terra vegetation indices 16-day L3 global 250 m SIN grid V061 [Data set]. NASA EOSDIS Land Processes Distributed Active Archive Center. https://doi.org/10.5067/MODIS/MOD13Q1.061</a:t>
+            </a:r>
+          </a:p>
+          <a:p>
+            <a:pPr algn="l" marL="274320" indent="-274320">
+              <a:lnSpc>
+                <a:spcPct val="132000"/>
+              </a:lnSpc>
+              <a:spcAft>
+                <a:spcPts val="1200"/>
+              </a:spcAft>
+            </a:pPr>
+            <a:r>
+              <a:rPr sz="1220" b="0" i="0">
+                <a:solidFill>
+                  <a:srgbClr val="0F2A35"/>
+                </a:solidFill>
+                <a:latin typeface="Calibri"/>
+              </a:rPr>
+              <a:t>Friedman, J. H. (2001). Greedy function approximation: A gradient boosting machine. The Annals of Statistics, 29(5), 1189–1232. https://doi.org/10.1214/aos/1013203451</a:t>
+            </a:r>
+          </a:p>
+          <a:p>
+            <a:pPr algn="l" marL="274320" indent="-274320">
+              <a:lnSpc>
+                <a:spcPct val="132000"/>
+              </a:lnSpc>
+              <a:spcAft>
+                <a:spcPts val="1200"/>
+              </a:spcAft>
+            </a:pPr>
+            <a:r>
+              <a:rPr sz="1220" b="0" i="0">
+                <a:solidFill>
+                  <a:srgbClr val="0F2A35"/>
+                </a:solidFill>
+                <a:latin typeface="Calibri"/>
+              </a:rPr>
+              <a:t>Gorelick, N., Hancher, M., Dixon, M., Ilyushchenko, S., Thau, D., &amp; Moore, R. (2017). Google Earth Engine: Planetary-scale geospatial analysis for everyone. Remote Sensing of Environment, 202, 18–27. https://doi.org/10.1016/j.rse.2017.06.031</a:t>
+            </a:r>
+          </a:p>
+          <a:p>
+            <a:pPr algn="l" marL="274320" indent="-274320">
+              <a:lnSpc>
+                <a:spcPct val="132000"/>
+              </a:lnSpc>
+              <a:spcAft>
+                <a:spcPts val="1200"/>
+              </a:spcAft>
+            </a:pPr>
+            <a:r>
+              <a:rPr sz="1220" b="0" i="0">
+                <a:solidFill>
+                  <a:srgbClr val="0F2A35"/>
+                </a:solidFill>
+                <a:latin typeface="Calibri"/>
+              </a:rPr>
+              <a:t>Harris, C. R., Millman, K. J., van der Walt, S. J., Gommers, R., Virtanen, P., Cournapeau, D., … Oliphant, T. E. (2020). Array programming with NumPy. Nature, 585(7825), 357–362. https://doi.org/10.1038/s41586-020-2649-2</a:t>
+            </a:r>
+          </a:p>
+          <a:p>
+            <a:pPr algn="l" marL="274320" indent="-274320">
+              <a:lnSpc>
+                <a:spcPct val="132000"/>
+              </a:lnSpc>
+              <a:spcAft>
+                <a:spcPts val="1200"/>
+              </a:spcAft>
+            </a:pPr>
+            <a:r>
+              <a:rPr sz="1220" b="0" i="0">
+                <a:solidFill>
+                  <a:srgbClr val="0F2A35"/>
+                </a:solidFill>
+                <a:latin typeface="Calibri"/>
+              </a:rPr>
+              <a:t>Hochreiter, S., &amp; Schmidhuber, J. (1997). Long short-term memory. Neural Computation, 9(8), 1735–1780. https://doi.org/10.1162/neco.1997.9.8.1735</a:t>
+            </a:r>
+          </a:p>
+          <a:p>
+            <a:pPr algn="l" marL="274320" indent="-274320">
+              <a:lnSpc>
+                <a:spcPct val="132000"/>
+              </a:lnSpc>
+              <a:spcAft>
+                <a:spcPts val="1200"/>
+              </a:spcAft>
+            </a:pPr>
+            <a:r>
+              <a:rPr sz="1220" b="0" i="0">
+                <a:solidFill>
+                  <a:srgbClr val="0F2A35"/>
+                </a:solidFill>
+                <a:latin typeface="Calibri"/>
+              </a:rPr>
+              <a:t>Hunter, J. D. (2007). Matplotlib: A 2D graphics environment. Computing in Science &amp; Engineering, 9(3), 90–95. https://doi.org/10.1109/MCSE.2007.55</a:t>
+            </a:r>
+          </a:p>
+        </p:txBody>
+      </p:sp>
+      <p:sp>
+        <p:nvSpPr>
+          <p:cNvPr id="6" name="TextBox 5"/>
+          <p:cNvSpPr txBox="1"/>
+          <p:nvPr/>
+        </p:nvSpPr>
+        <p:spPr>
+          <a:xfrm>
+            <a:off x="822960" y="6327648"/>
+            <a:ext cx="5486400" cy="274320"/>
+          </a:xfrm>
+          <a:prstGeom prst="rect">
+            <a:avLst/>
+          </a:prstGeom>
+          <a:noFill/>
+        </p:spPr>
+        <p:txBody>
+          <a:bodyPr wrap="square" anchor="t" lIns="0" rIns="0" tIns="0" bIns="0">
+            <a:spAutoFit/>
+          </a:bodyPr>
+          <a:lstStyle/>
+          <a:p>
+            <a:pPr algn="l">
+              <a:lnSpc>
+                <a:spcPct val="125000"/>
+              </a:lnSpc>
+              <a:spcAft>
+                <a:spcPts val="0"/>
+              </a:spcAft>
+            </a:pPr>
+            <a:r>
+              <a:rPr sz="1000" b="0" i="0">
+                <a:solidFill>
+                  <a:srgbClr val="6B7C85"/>
+                </a:solidFill>
+                <a:latin typeface="Calibri"/>
+              </a:rPr>
+              <a:t/>
+            </a:r>
+          </a:p>
+        </p:txBody>
+      </p:sp>
+      <p:sp>
+        <p:nvSpPr>
+          <p:cNvPr id="7" name="TextBox 6"/>
+          <p:cNvSpPr txBox="1"/>
+          <p:nvPr/>
+        </p:nvSpPr>
+        <p:spPr>
+          <a:xfrm>
+            <a:off x="9601200" y="6327648"/>
+            <a:ext cx="1828800" cy="274320"/>
+          </a:xfrm>
+          <a:prstGeom prst="rect">
+            <a:avLst/>
+          </a:prstGeom>
+          <a:noFill/>
+        </p:spPr>
+        <p:txBody>
+          <a:bodyPr wrap="square" anchor="t" lIns="0" rIns="0" tIns="0" bIns="0">
+            <a:spAutoFit/>
+          </a:bodyPr>
+          <a:lstStyle/>
+          <a:p>
+            <a:pPr algn="r">
+              <a:lnSpc>
+                <a:spcPct val="125000"/>
+              </a:lnSpc>
+              <a:spcAft>
+                <a:spcPts val="0"/>
+              </a:spcAft>
+            </a:pPr>
+            <a:r>
+              <a:rPr sz="1000" b="0" i="0">
+                <a:solidFill>
+                  <a:srgbClr val="6B7C85"/>
+                </a:solidFill>
+                <a:latin typeface="Calibri"/>
+              </a:rPr>
+              <a:t>23</a:t>
+            </a:r>
+          </a:p>
+        </p:txBody>
+      </p:sp>
+    </p:spTree>
+  </p:cSld>
+  <p:clrMapOvr>
+    <a:masterClrMapping/>
+  </p:clrMapOvr>
+</p:sld>
+</file>
+
+<file path=ppt/slides/slide24.xml><?xml version="1.0" encoding="utf-8"?>
+<p:sld xmlns:a="http://schemas.openxmlformats.org/drawingml/2006/main" xmlns:p="http://schemas.openxmlformats.org/presentationml/2006/main" xmlns:r="http://schemas.openxmlformats.org/officeDocument/2006/relationships">
+  <p:cSld>
+    <p:bg>
+      <p:bgPr>
+        <a:solidFill>
+          <a:srgbClr val="F7F5F2"/>
+        </a:solidFill>
+        <a:effectLst/>
+      </p:bgPr>
+    </p:bg>
+    <p:spTree>
+      <p:nvGrpSpPr>
+        <p:cNvPr id="1" name=""/>
+        <p:cNvGrpSpPr/>
+        <p:nvPr/>
+      </p:nvGrpSpPr>
+      <p:grpSpPr/>
+      <p:sp>
+        <p:nvSpPr>
+          <p:cNvPr id="2" name="TextBox 1"/>
+          <p:cNvSpPr txBox="1"/>
+          <p:nvPr/>
+        </p:nvSpPr>
+        <p:spPr>
+          <a:xfrm>
+            <a:off x="822960" y="310896"/>
+            <a:ext cx="10607040" cy="274320"/>
+          </a:xfrm>
+          <a:prstGeom prst="rect">
+            <a:avLst/>
+          </a:prstGeom>
+          <a:noFill/>
+        </p:spPr>
+        <p:txBody>
+          <a:bodyPr wrap="square" anchor="t" lIns="0" rIns="0" tIns="0" bIns="0">
+            <a:spAutoFit/>
+          </a:bodyPr>
+          <a:lstStyle/>
+          <a:p>
+            <a:pPr algn="l">
+              <a:lnSpc>
+                <a:spcPct val="100000"/>
+              </a:lnSpc>
+              <a:spcAft>
+                <a:spcPts val="0"/>
+              </a:spcAft>
+            </a:pPr>
+            <a:r>
+              <a:rPr sz="1100" b="1" i="0">
+                <a:solidFill>
+                  <a:srgbClr val="C8552F"/>
+                </a:solidFill>
+                <a:latin typeface="Calibri"/>
+              </a:rPr>
+              <a:t>REFERENCES</a:t>
+            </a:r>
+          </a:p>
+        </p:txBody>
+      </p:sp>
+      <p:sp>
+        <p:nvSpPr>
+          <p:cNvPr id="3" name="TextBox 2"/>
+          <p:cNvSpPr txBox="1"/>
+          <p:nvPr/>
+        </p:nvSpPr>
+        <p:spPr>
+          <a:xfrm>
+            <a:off x="822960" y="566928"/>
+            <a:ext cx="10607040" cy="914400"/>
+          </a:xfrm>
+          <a:prstGeom prst="rect">
+            <a:avLst/>
+          </a:prstGeom>
+          <a:noFill/>
+        </p:spPr>
+        <p:txBody>
+          <a:bodyPr wrap="square" anchor="t" lIns="0" rIns="0" tIns="0" bIns="0">
+            <a:spAutoFit/>
+          </a:bodyPr>
+          <a:lstStyle/>
+          <a:p>
+            <a:pPr algn="l">
+              <a:lnSpc>
+                <a:spcPct val="105000"/>
+              </a:lnSpc>
+              <a:spcAft>
+                <a:spcPts val="0"/>
+              </a:spcAft>
+            </a:pPr>
+            <a:r>
+              <a:rPr sz="3400" b="1" i="0">
+                <a:solidFill>
+                  <a:srgbClr val="0F2A35"/>
+                </a:solidFill>
+                <a:latin typeface="Cambria"/>
+              </a:rPr>
+              <a:t>References (2 of 2)</a:t>
+            </a:r>
+          </a:p>
+        </p:txBody>
+      </p:sp>
+      <p:sp>
+        <p:nvSpPr>
+          <p:cNvPr id="4" name="TextBox 3"/>
+          <p:cNvSpPr txBox="1"/>
+          <p:nvPr/>
+        </p:nvSpPr>
+        <p:spPr>
+          <a:xfrm>
+            <a:off x="822960" y="1572768"/>
+            <a:ext cx="10515600" cy="292608"/>
+          </a:xfrm>
+          <a:prstGeom prst="rect">
+            <a:avLst/>
+          </a:prstGeom>
+          <a:noFill/>
+        </p:spPr>
+        <p:txBody>
+          <a:bodyPr wrap="square" anchor="t" lIns="0" rIns="0" tIns="0" bIns="0">
+            <a:spAutoFit/>
+          </a:bodyPr>
+          <a:lstStyle/>
+          <a:p>
+            <a:pPr algn="l">
+              <a:lnSpc>
+                <a:spcPct val="125000"/>
+              </a:lnSpc>
+              <a:spcAft>
+                <a:spcPts val="0"/>
+              </a:spcAft>
+            </a:pPr>
+            <a:r>
+              <a:rPr sz="1150" b="0" i="0">
+                <a:solidFill>
+                  <a:srgbClr val="6B7C85"/>
+                </a:solidFill>
+                <a:latin typeface="Calibri"/>
+              </a:rPr>
+              <a:t>American Psychological Association, 7th edition</a:t>
+            </a:r>
+          </a:p>
+        </p:txBody>
+      </p:sp>
+      <p:sp>
+        <p:nvSpPr>
+          <p:cNvPr id="5" name="TextBox 4"/>
+          <p:cNvSpPr txBox="1"/>
+          <p:nvPr/>
+        </p:nvSpPr>
+        <p:spPr>
+          <a:xfrm>
+            <a:off x="822960" y="2029968"/>
+            <a:ext cx="10515600" cy="4023360"/>
+          </a:xfrm>
+          <a:prstGeom prst="rect">
+            <a:avLst/>
+          </a:prstGeom>
+          <a:noFill/>
+        </p:spPr>
+        <p:txBody>
+          <a:bodyPr wrap="square" anchor="t" lIns="0" rIns="0" tIns="0" bIns="0">
+            <a:spAutoFit/>
+          </a:bodyPr>
+          <a:lstStyle/>
+          <a:p>
+            <a:pPr algn="l" marL="274320" indent="-274320">
+              <a:lnSpc>
+                <a:spcPct val="132000"/>
+              </a:lnSpc>
+              <a:spcAft>
+                <a:spcPts val="1200"/>
+              </a:spcAft>
+            </a:pPr>
+            <a:r>
+              <a:rPr sz="1220" b="0" i="0">
+                <a:solidFill>
+                  <a:srgbClr val="0F2A35"/>
+                </a:solidFill>
+                <a:latin typeface="Calibri"/>
+              </a:rPr>
+              <a:t>Jeffrey, S. J., Carter, J. O., Moodie, K. B., &amp; Beswick, A. R. (2001). Using spatial interpolation to construct a comprehensive archive of Australian climate data. Environmental Modelling &amp; Software, 16(4), 309–330. https://doi.org/10.1016/S1364-8152(01)00008-1</a:t>
+            </a:r>
+          </a:p>
+          <a:p>
+            <a:pPr algn="l" marL="274320" indent="-274320">
+              <a:lnSpc>
+                <a:spcPct val="132000"/>
+              </a:lnSpc>
+              <a:spcAft>
+                <a:spcPts val="1200"/>
+              </a:spcAft>
+            </a:pPr>
+            <a:r>
+              <a:rPr sz="1220" b="0" i="0">
+                <a:solidFill>
+                  <a:srgbClr val="0F2A35"/>
+                </a:solidFill>
+                <a:latin typeface="Calibri"/>
+              </a:rPr>
+              <a:t>North Australian Fire Information. (2026). Northern Territory fire scar mapping [Data set]. Darwin Centre for Bushfire Research, Charles Darwin University. https://firenorth.org.au</a:t>
+            </a:r>
+          </a:p>
+          <a:p>
+            <a:pPr algn="l" marL="274320" indent="-274320">
+              <a:lnSpc>
+                <a:spcPct val="132000"/>
+              </a:lnSpc>
+              <a:spcAft>
+                <a:spcPts val="1200"/>
+              </a:spcAft>
+            </a:pPr>
+            <a:r>
+              <a:rPr sz="1220" b="0" i="0">
+                <a:solidFill>
+                  <a:srgbClr val="0F2A35"/>
+                </a:solidFill>
+                <a:latin typeface="Calibri"/>
+              </a:rPr>
+              <a:t>Pedregosa, F., Varoquaux, G., Gramfort, A., Michel, V., Thirion, B., Grisel, O., … Duchesnay, É. (2011). Scikit-learn: Machine learning in Python. Journal of Machine Learning Research, 12, 2825–2830.</a:t>
+            </a:r>
+          </a:p>
+          <a:p>
+            <a:pPr algn="l" marL="274320" indent="-274320">
+              <a:lnSpc>
+                <a:spcPct val="132000"/>
+              </a:lnSpc>
+              <a:spcAft>
+                <a:spcPts val="1200"/>
+              </a:spcAft>
+            </a:pPr>
+            <a:r>
+              <a:rPr sz="1220" b="0" i="0">
+                <a:solidFill>
+                  <a:srgbClr val="0F2A35"/>
+                </a:solidFill>
+                <a:latin typeface="Calibri"/>
+              </a:rPr>
+              <a:t>Queensland Government. (2026). SILO climate data: Data Drill [Data set]. Long Paddock. https://www.longpaddock.qld.gov.au/silo/</a:t>
+            </a:r>
+          </a:p>
+          <a:p>
+            <a:pPr algn="l" marL="274320" indent="-274320">
+              <a:lnSpc>
+                <a:spcPct val="132000"/>
+              </a:lnSpc>
+              <a:spcAft>
+                <a:spcPts val="1200"/>
+              </a:spcAft>
+            </a:pPr>
+            <a:r>
+              <a:rPr sz="1220" b="0" i="0">
+                <a:solidFill>
+                  <a:srgbClr val="0F2A35"/>
+                </a:solidFill>
+                <a:latin typeface="Calibri"/>
+              </a:rPr>
+              <a:t>Ronneberger, O., Fischer, P., &amp; Brox, T. (2015). U-Net: Convolutional networks for biomedical image segmentation. In N. Navab, J. Hornegger, W. M. Wells, &amp; A. F. Frangi (Eds.), Medical image computing and computer-assisted intervention – MICCAI 2015 (pp. 234–241). Springer. https://doi.org/10.1007/978-3-319-24574-4_28</a:t>
+            </a:r>
+          </a:p>
+          <a:p>
+            <a:pPr algn="l" marL="274320" indent="-274320">
+              <a:lnSpc>
+                <a:spcPct val="132000"/>
+              </a:lnSpc>
+              <a:spcAft>
+                <a:spcPts val="1200"/>
+              </a:spcAft>
+            </a:pPr>
+            <a:r>
+              <a:rPr sz="1220" b="0" i="0">
+                <a:solidFill>
+                  <a:srgbClr val="0F2A35"/>
+                </a:solidFill>
+                <a:latin typeface="Calibri"/>
+              </a:rPr>
+              <a:t>Russell-Smith, J., Yates, C. P., Whitehead, P. J., Smith, R., Craig, R., Allan, G. E., Thackway, R., Frakes, I., Cridland, S., Meyer, M. C. P., &amp; Gill, A. M. (2007). Bushfires 'down under': Patterns and implications of contemporary Australian landscape burning. International Journal of Wildland Fire, 16(4), 361–377. https://doi.org/10.1071/WF07018</a:t>
+            </a:r>
+          </a:p>
+        </p:txBody>
+      </p:sp>
+      <p:sp>
+        <p:nvSpPr>
+          <p:cNvPr id="6" name="TextBox 5"/>
+          <p:cNvSpPr txBox="1"/>
+          <p:nvPr/>
+        </p:nvSpPr>
+        <p:spPr>
+          <a:xfrm>
+            <a:off x="822960" y="6327648"/>
+            <a:ext cx="5486400" cy="274320"/>
+          </a:xfrm>
+          <a:prstGeom prst="rect">
+            <a:avLst/>
+          </a:prstGeom>
+          <a:noFill/>
+        </p:spPr>
+        <p:txBody>
+          <a:bodyPr wrap="square" anchor="t" lIns="0" rIns="0" tIns="0" bIns="0">
+            <a:spAutoFit/>
+          </a:bodyPr>
+          <a:lstStyle/>
+          <a:p>
+            <a:pPr algn="l">
+              <a:lnSpc>
+                <a:spcPct val="125000"/>
+              </a:lnSpc>
+              <a:spcAft>
+                <a:spcPts val="0"/>
+              </a:spcAft>
+            </a:pPr>
+            <a:r>
+              <a:rPr sz="1000" b="0" i="0">
+                <a:solidFill>
+                  <a:srgbClr val="6B7C85"/>
+                </a:solidFill>
+                <a:latin typeface="Calibri"/>
+              </a:rPr>
+              <a:t/>
+            </a:r>
+          </a:p>
+        </p:txBody>
+      </p:sp>
+      <p:sp>
+        <p:nvSpPr>
+          <p:cNvPr id="7" name="TextBox 6"/>
+          <p:cNvSpPr txBox="1"/>
+          <p:nvPr/>
+        </p:nvSpPr>
+        <p:spPr>
+          <a:xfrm>
+            <a:off x="9601200" y="6327648"/>
+            <a:ext cx="1828800" cy="274320"/>
+          </a:xfrm>
+          <a:prstGeom prst="rect">
+            <a:avLst/>
+          </a:prstGeom>
+          <a:noFill/>
+        </p:spPr>
+        <p:txBody>
+          <a:bodyPr wrap="square" anchor="t" lIns="0" rIns="0" tIns="0" bIns="0">
+            <a:spAutoFit/>
+          </a:bodyPr>
+          <a:lstStyle/>
+          <a:p>
+            <a:pPr algn="r">
+              <a:lnSpc>
+                <a:spcPct val="125000"/>
+              </a:lnSpc>
+              <a:spcAft>
+                <a:spcPts val="0"/>
+              </a:spcAft>
+            </a:pPr>
+            <a:r>
+              <a:rPr sz="1000" b="0" i="0">
+                <a:solidFill>
+                  <a:srgbClr val="6B7C85"/>
+                </a:solidFill>
+                <a:latin typeface="Calibri"/>
+              </a:rPr>
+              <a:t>24</a:t>
             </a:r>
           </a:p>
         </p:txBody>

</xml_diff>

<commit_message>
point the deck and script at the URL that actually resolves
pyrantis.harshrastogi.workers.dev does not exist -- the workers.dev subdomain
is harshlabs. The cover slide, the closing slide and the script cover all
carried the dead address.
</commit_message>
<xml_diff>
--- a/reports/PYRANTIS_presentation.pptx
+++ b/reports/PYRANTIS_presentation.pptx
@@ -6244,7 +6244,7 @@
                 </a:solidFill>
                 <a:latin typeface="Calibri"/>
               </a:rPr>
-              <a:t>pyrantis.harshrastogi.workers.dev</a:t>
+              <a:t>pyrantis.harshlabs.workers.dev</a:t>
             </a:r>
           </a:p>
         </p:txBody>
@@ -13924,7 +13924,7 @@
                 </a:solidFill>
                 <a:latin typeface="Calibri"/>
               </a:rPr>
-              <a:t>pyrantis.harshrastogi.workers.dev</a:t>
+              <a:t>pyrantis.harshlabs.workers.dev</a:t>
             </a:r>
           </a:p>
           <a:p>

</xml_diff>

<commit_message>
correct three claims the audit caught
The feature families on slide 8 said 22/14/8, which is neither the real split
nor 50: it is 26 fire history, 14 weather, 7 greenness and 3 that place the
square. The CNN sat 0.048 below the benchmark, not 0.086 -- that figure was its
gap to the LSTM. And the third ablation run adds long memory and elevation
alongside greenness, so the bar is now labelled for all three, with the
ledger's isolated greenness gain of +0.029 quoted beside it.
</commit_message>
<xml_diff>
--- a/reports/PYRANTIS_presentation.pptx
+++ b/reports/PYRANTIS_presentation.pptx
@@ -9484,7 +9484,7 @@
         <p:spPr>
           <a:xfrm>
             <a:off x="731520" y="1828800"/>
-            <a:ext cx="5809350" cy="3657600"/>
+            <a:ext cx="5857460" cy="3657599"/>
           </a:xfrm>
           <a:prstGeom prst="rect">
             <a:avLst/>
@@ -9499,8 +9499,8 @@
         </p:nvSpPr>
         <p:spPr>
           <a:xfrm>
-            <a:off x="7863840" y="1883664"/>
-            <a:ext cx="3566160" cy="3108960"/>
+            <a:off x="7863840" y="1810512"/>
+            <a:ext cx="3611880" cy="3749039"/>
           </a:xfrm>
           <a:prstGeom prst="rect">
             <a:avLst/>
@@ -9547,7 +9547,7 @@
                 </a:solidFill>
                 <a:latin typeface="Calibri"/>
               </a:rPr>
-              <a:t>Satellite greenness added +0.010 on top of that. Small, real, and expensive: the Earth Engine extraction took ten minutes a run against sixty seconds for the rest.</a:t>
+              <a:t>The third run adds greenness, longer fire memory and elevation together, for +0.010. Isolated in the experiment ledger, greenness on its own is worth +0.029.</a:t>
             </a:r>
           </a:p>
           <a:p>
@@ -9566,7 +9566,7 @@
                 </a:solidFill>
                 <a:latin typeface="Calibri"/>
               </a:rPr>
-              <a:t>We kept it, because it holds up on years the model never saw and because two of the model's five strongest inputs turn out to be greenness. But we are not going to call a 0.010 gain a breakthrough.</a:t>
+              <a:t>We kept it, because it holds up on years the model never saw and because two of the model's five strongest inputs turn out to be greenness — even though Earth Engine cost ten minutes a run against sixty seconds for everything else.</a:t>
             </a:r>
           </a:p>
         </p:txBody>
@@ -10376,7 +10376,7 @@
                 </a:solidFill>
                 <a:latin typeface="Calibri"/>
               </a:rPr>
-              <a:t>It scored 0.588 — 0.086 below the benchmark — so it went in the ledger as a reverted run and stayed out of the final model.</a:t>
+              <a:t>It scored 0.588 — 0.048 below the benchmark — so it went in the ledger as a reverted run and stayed out of the final model.</a:t>
             </a:r>
           </a:p>
           <a:p>
@@ -18703,8 +18703,8 @@
         </p:nvSpPr>
         <p:spPr>
           <a:xfrm>
-            <a:off x="822960" y="2788920"/>
-            <a:ext cx="10515600" cy="1005840"/>
+            <a:off x="822960" y="2615184"/>
+            <a:ext cx="10515600" cy="822960"/>
           </a:xfrm>
           <a:prstGeom prst="roundRect">
             <a:avLst>
@@ -18747,7 +18747,7 @@
         </p:nvSpPr>
         <p:spPr>
           <a:xfrm>
-            <a:off x="1170432" y="3200400"/>
+            <a:off x="1170432" y="2935224"/>
             <a:ext cx="182880" cy="182880"/>
           </a:xfrm>
           <a:prstGeom prst="roundRect">
@@ -18791,8 +18791,8 @@
         </p:nvSpPr>
         <p:spPr>
           <a:xfrm>
-            <a:off x="1517904" y="2971800"/>
-            <a:ext cx="2286000" cy="320040"/>
+            <a:off x="1517904" y="2734056"/>
+            <a:ext cx="2286000" cy="292608"/>
           </a:xfrm>
           <a:prstGeom prst="rect">
             <a:avLst/>
@@ -18814,7 +18814,7 @@
               </a:spcAft>
             </a:pPr>
             <a:r>
-              <a:rPr sz="1700" b="1" i="0">
+              <a:rPr sz="1600" b="1" i="0">
                 <a:solidFill>
                   <a:srgbClr val="0F2A35"/>
                 </a:solidFill>
@@ -18833,8 +18833,8 @@
         </p:nvSpPr>
         <p:spPr>
           <a:xfrm>
-            <a:off x="1517904" y="3355848"/>
-            <a:ext cx="2286000" cy="274320"/>
+            <a:off x="1517904" y="3072384"/>
+            <a:ext cx="2286000" cy="256032"/>
           </a:xfrm>
           <a:prstGeom prst="rect">
             <a:avLst/>
@@ -18856,13 +18856,13 @@
               </a:spcAft>
             </a:pPr>
             <a:r>
-              <a:rPr sz="1150" b="0" i="0">
+              <a:rPr sz="1100" b="0" i="0">
                 <a:solidFill>
                   <a:srgbClr val="6B7C85"/>
                 </a:solidFill>
                 <a:latin typeface="Calibri"/>
               </a:rPr>
-              <a:t>22 features</a:t>
+              <a:t>26 features</a:t>
             </a:r>
           </a:p>
         </p:txBody>
@@ -18875,30 +18875,30 @@
         </p:nvSpPr>
         <p:spPr>
           <a:xfrm>
-            <a:off x="4023360" y="3008376"/>
-            <a:ext cx="6949440" cy="685800"/>
-          </a:xfrm>
-          <a:prstGeom prst="rect">
-            <a:avLst/>
-          </a:prstGeom>
-          <a:noFill/>
-        </p:spPr>
-        <p:txBody>
-          <a:bodyPr wrap="square" anchor="t" lIns="0" rIns="0" tIns="0" bIns="0">
-            <a:spAutoFit/>
-          </a:bodyPr>
-          <a:lstStyle/>
-          <a:p>
-            <a:pPr algn="l">
-              <a:lnSpc>
-                <a:spcPct val="140000"/>
-              </a:lnSpc>
-              <a:spcAft>
-                <a:spcPts val="0"/>
-              </a:spcAft>
-            </a:pPr>
-            <a:r>
-              <a:rPr sz="1250" b="0" i="0">
+            <a:off x="4023360" y="2761488"/>
+            <a:ext cx="6949440" cy="566928"/>
+          </a:xfrm>
+          <a:prstGeom prst="rect">
+            <a:avLst/>
+          </a:prstGeom>
+          <a:noFill/>
+        </p:spPr>
+        <p:txBody>
+          <a:bodyPr wrap="square" anchor="t" lIns="0" rIns="0" tIns="0" bIns="0">
+            <a:spAutoFit/>
+          </a:bodyPr>
+          <a:lstStyle/>
+          <a:p>
+            <a:pPr algn="l">
+              <a:lnSpc>
+                <a:spcPct val="136000"/>
+              </a:lnSpc>
+              <a:spcAft>
+                <a:spcPts val="0"/>
+              </a:spcAft>
+            </a:pPr>
+            <a:r>
+              <a:rPr sz="1200" b="0" i="0">
                 <a:solidFill>
                   <a:srgbClr val="0F2A35"/>
                 </a:solidFill>
@@ -18917,8 +18917,8 @@
         </p:nvSpPr>
         <p:spPr>
           <a:xfrm>
-            <a:off x="822960" y="3922776"/>
-            <a:ext cx="10515600" cy="1005840"/>
+            <a:off x="822960" y="3520439"/>
+            <a:ext cx="10515600" cy="822960"/>
           </a:xfrm>
           <a:prstGeom prst="roundRect">
             <a:avLst>
@@ -18961,7 +18961,7 @@
         </p:nvSpPr>
         <p:spPr>
           <a:xfrm>
-            <a:off x="1170432" y="4334256"/>
+            <a:off x="1170432" y="3840479"/>
             <a:ext cx="182880" cy="182880"/>
           </a:xfrm>
           <a:prstGeom prst="roundRect">
@@ -19005,8 +19005,8 @@
         </p:nvSpPr>
         <p:spPr>
           <a:xfrm>
-            <a:off x="1517904" y="4105656"/>
-            <a:ext cx="2286000" cy="320040"/>
+            <a:off x="1517904" y="3639311"/>
+            <a:ext cx="2286000" cy="292608"/>
           </a:xfrm>
           <a:prstGeom prst="rect">
             <a:avLst/>
@@ -19028,7 +19028,7 @@
               </a:spcAft>
             </a:pPr>
             <a:r>
-              <a:rPr sz="1700" b="1" i="0">
+              <a:rPr sz="1600" b="1" i="0">
                 <a:solidFill>
                   <a:srgbClr val="0F2A35"/>
                 </a:solidFill>
@@ -19047,8 +19047,8 @@
         </p:nvSpPr>
         <p:spPr>
           <a:xfrm>
-            <a:off x="1517904" y="4489704"/>
-            <a:ext cx="2286000" cy="274320"/>
+            <a:off x="1517904" y="3977639"/>
+            <a:ext cx="2286000" cy="256032"/>
           </a:xfrm>
           <a:prstGeom prst="rect">
             <a:avLst/>
@@ -19070,7 +19070,7 @@
               </a:spcAft>
             </a:pPr>
             <a:r>
-              <a:rPr sz="1150" b="0" i="0">
+              <a:rPr sz="1100" b="0" i="0">
                 <a:solidFill>
                   <a:srgbClr val="6B7C85"/>
                 </a:solidFill>
@@ -19089,30 +19089,30 @@
         </p:nvSpPr>
         <p:spPr>
           <a:xfrm>
-            <a:off x="4023360" y="4142232"/>
-            <a:ext cx="6949440" cy="685800"/>
-          </a:xfrm>
-          <a:prstGeom prst="rect">
-            <a:avLst/>
-          </a:prstGeom>
-          <a:noFill/>
-        </p:spPr>
-        <p:txBody>
-          <a:bodyPr wrap="square" anchor="t" lIns="0" rIns="0" tIns="0" bIns="0">
-            <a:spAutoFit/>
-          </a:bodyPr>
-          <a:lstStyle/>
-          <a:p>
-            <a:pPr algn="l">
-              <a:lnSpc>
-                <a:spcPct val="140000"/>
-              </a:lnSpc>
-              <a:spcAft>
-                <a:spcPts val="0"/>
-              </a:spcAft>
-            </a:pPr>
-            <a:r>
-              <a:rPr sz="1250" b="0" i="0">
+            <a:off x="4023360" y="3666744"/>
+            <a:ext cx="6949440" cy="566928"/>
+          </a:xfrm>
+          <a:prstGeom prst="rect">
+            <a:avLst/>
+          </a:prstGeom>
+          <a:noFill/>
+        </p:spPr>
+        <p:txBody>
+          <a:bodyPr wrap="square" anchor="t" lIns="0" rIns="0" tIns="0" bIns="0">
+            <a:spAutoFit/>
+          </a:bodyPr>
+          <a:lstStyle/>
+          <a:p>
+            <a:pPr algn="l">
+              <a:lnSpc>
+                <a:spcPct val="136000"/>
+              </a:lnSpc>
+              <a:spcAft>
+                <a:spcPts val="0"/>
+              </a:spcAft>
+            </a:pPr>
+            <a:r>
+              <a:rPr sz="1200" b="0" i="0">
                 <a:solidFill>
                   <a:srgbClr val="0F2A35"/>
                 </a:solidFill>
@@ -19131,8 +19131,8 @@
         </p:nvSpPr>
         <p:spPr>
           <a:xfrm>
-            <a:off x="822960" y="5056632"/>
-            <a:ext cx="10515600" cy="1005840"/>
+            <a:off x="822960" y="4425696"/>
+            <a:ext cx="10515600" cy="822960"/>
           </a:xfrm>
           <a:prstGeom prst="roundRect">
             <a:avLst>
@@ -19175,7 +19175,7 @@
         </p:nvSpPr>
         <p:spPr>
           <a:xfrm>
-            <a:off x="1170432" y="5468112"/>
+            <a:off x="1170432" y="4745736"/>
             <a:ext cx="182880" cy="182880"/>
           </a:xfrm>
           <a:prstGeom prst="roundRect">
@@ -19219,8 +19219,8 @@
         </p:nvSpPr>
         <p:spPr>
           <a:xfrm>
-            <a:off x="1517904" y="5239512"/>
-            <a:ext cx="2286000" cy="320040"/>
+            <a:off x="1517904" y="4544568"/>
+            <a:ext cx="2286000" cy="292608"/>
           </a:xfrm>
           <a:prstGeom prst="rect">
             <a:avLst/>
@@ -19242,7 +19242,7 @@
               </a:spcAft>
             </a:pPr>
             <a:r>
-              <a:rPr sz="1700" b="1" i="0">
+              <a:rPr sz="1600" b="1" i="0">
                 <a:solidFill>
                   <a:srgbClr val="0F2A35"/>
                 </a:solidFill>
@@ -19261,8 +19261,8 @@
         </p:nvSpPr>
         <p:spPr>
           <a:xfrm>
-            <a:off x="1517904" y="5623560"/>
-            <a:ext cx="2286000" cy="274320"/>
+            <a:off x="1517904" y="4882896"/>
+            <a:ext cx="2286000" cy="256032"/>
           </a:xfrm>
           <a:prstGeom prst="rect">
             <a:avLst/>
@@ -19284,13 +19284,13 @@
               </a:spcAft>
             </a:pPr>
             <a:r>
-              <a:rPr sz="1150" b="0" i="0">
+              <a:rPr sz="1100" b="0" i="0">
                 <a:solidFill>
                   <a:srgbClr val="6B7C85"/>
                 </a:solidFill>
                 <a:latin typeface="Calibri"/>
               </a:rPr>
-              <a:t>8 features</a:t>
+              <a:t>7 features</a:t>
             </a:r>
           </a:p>
         </p:txBody>
@@ -19303,30 +19303,30 @@
         </p:nvSpPr>
         <p:spPr>
           <a:xfrm>
-            <a:off x="4023360" y="5276088"/>
-            <a:ext cx="6949440" cy="685800"/>
-          </a:xfrm>
-          <a:prstGeom prst="rect">
-            <a:avLst/>
-          </a:prstGeom>
-          <a:noFill/>
-        </p:spPr>
-        <p:txBody>
-          <a:bodyPr wrap="square" anchor="t" lIns="0" rIns="0" tIns="0" bIns="0">
-            <a:spAutoFit/>
-          </a:bodyPr>
-          <a:lstStyle/>
-          <a:p>
-            <a:pPr algn="l">
-              <a:lnSpc>
-                <a:spcPct val="140000"/>
-              </a:lnSpc>
-              <a:spcAft>
-                <a:spcPts val="0"/>
-              </a:spcAft>
-            </a:pPr>
-            <a:r>
-              <a:rPr sz="1250" b="0" i="0">
+            <a:off x="4023360" y="4572000"/>
+            <a:ext cx="6949440" cy="566928"/>
+          </a:xfrm>
+          <a:prstGeom prst="rect">
+            <a:avLst/>
+          </a:prstGeom>
+          <a:noFill/>
+        </p:spPr>
+        <p:txBody>
+          <a:bodyPr wrap="square" anchor="t" lIns="0" rIns="0" tIns="0" bIns="0">
+            <a:spAutoFit/>
+          </a:bodyPr>
+          <a:lstStyle/>
+          <a:p>
+            <a:pPr algn="l">
+              <a:lnSpc>
+                <a:spcPct val="136000"/>
+              </a:lnSpc>
+              <a:spcAft>
+                <a:spcPts val="0"/>
+              </a:spcAft>
+            </a:pPr>
+            <a:r>
+              <a:rPr sz="1200" b="0" i="0">
                 <a:solidFill>
                   <a:srgbClr val="0F2A35"/>
                 </a:solidFill>
@@ -19339,7 +19339,221 @@
       </p:sp>
       <p:sp>
         <p:nvSpPr>
-          <p:cNvPr id="20" name="TextBox 19"/>
+          <p:cNvPr id="20" name="Rounded Rectangle 19"/>
+          <p:cNvSpPr/>
+          <p:nvPr/>
+        </p:nvSpPr>
+        <p:spPr>
+          <a:xfrm>
+            <a:off x="822960" y="5330952"/>
+            <a:ext cx="10515600" cy="822960"/>
+          </a:xfrm>
+          <a:prstGeom prst="roundRect">
+            <a:avLst>
+              <a:gd name="adj" fmla="val 5000"/>
+            </a:avLst>
+          </a:prstGeom>
+          <a:solidFill>
+            <a:srgbClr val="FFFFFF"/>
+          </a:solidFill>
+          <a:ln>
+            <a:noFill/>
+          </a:ln>
+          <a:effectLst/>
+        </p:spPr>
+        <p:style>
+          <a:lnRef idx="1">
+            <a:schemeClr val="accent1"/>
+          </a:lnRef>
+          <a:fillRef idx="3">
+            <a:schemeClr val="accent1"/>
+          </a:fillRef>
+          <a:effectRef idx="2">
+            <a:schemeClr val="accent1"/>
+          </a:effectRef>
+          <a:fontRef idx="minor">
+            <a:schemeClr val="lt1"/>
+          </a:fontRef>
+        </p:style>
+        <p:txBody>
+          <a:bodyPr rtlCol="0" anchor="ctr"/>
+          <a:lstStyle/>
+          <a:p/>
+        </p:txBody>
+      </p:sp>
+      <p:sp>
+        <p:nvSpPr>
+          <p:cNvPr id="21" name="Rounded Rectangle 20"/>
+          <p:cNvSpPr/>
+          <p:nvPr/>
+        </p:nvSpPr>
+        <p:spPr>
+          <a:xfrm>
+            <a:off x="1170432" y="5650992"/>
+            <a:ext cx="182880" cy="182880"/>
+          </a:xfrm>
+          <a:prstGeom prst="roundRect">
+            <a:avLst>
+              <a:gd name="adj" fmla="val 18000"/>
+            </a:avLst>
+          </a:prstGeom>
+          <a:solidFill>
+            <a:srgbClr val="9AA8AE"/>
+          </a:solidFill>
+          <a:ln>
+            <a:noFill/>
+          </a:ln>
+          <a:effectLst/>
+        </p:spPr>
+        <p:style>
+          <a:lnRef idx="1">
+            <a:schemeClr val="accent1"/>
+          </a:lnRef>
+          <a:fillRef idx="3">
+            <a:schemeClr val="accent1"/>
+          </a:fillRef>
+          <a:effectRef idx="2">
+            <a:schemeClr val="accent1"/>
+          </a:effectRef>
+          <a:fontRef idx="minor">
+            <a:schemeClr val="lt1"/>
+          </a:fontRef>
+        </p:style>
+        <p:txBody>
+          <a:bodyPr rtlCol="0" anchor="ctr"/>
+          <a:lstStyle/>
+          <a:p/>
+        </p:txBody>
+      </p:sp>
+      <p:sp>
+        <p:nvSpPr>
+          <p:cNvPr id="22" name="TextBox 21"/>
+          <p:cNvSpPr txBox="1"/>
+          <p:nvPr/>
+        </p:nvSpPr>
+        <p:spPr>
+          <a:xfrm>
+            <a:off x="1517904" y="5449824"/>
+            <a:ext cx="2286000" cy="292608"/>
+          </a:xfrm>
+          <a:prstGeom prst="rect">
+            <a:avLst/>
+          </a:prstGeom>
+          <a:noFill/>
+        </p:spPr>
+        <p:txBody>
+          <a:bodyPr wrap="square" anchor="t" lIns="0" rIns="0" tIns="0" bIns="0">
+            <a:spAutoFit/>
+          </a:bodyPr>
+          <a:lstStyle/>
+          <a:p>
+            <a:pPr algn="l">
+              <a:lnSpc>
+                <a:spcPct val="125000"/>
+              </a:lnSpc>
+              <a:spcAft>
+                <a:spcPts val="0"/>
+              </a:spcAft>
+            </a:pPr>
+            <a:r>
+              <a:rPr sz="1600" b="1" i="0">
+                <a:solidFill>
+                  <a:srgbClr val="0F2A35"/>
+                </a:solidFill>
+                <a:latin typeface="Cambria"/>
+              </a:rPr>
+              <a:t>Place</a:t>
+            </a:r>
+          </a:p>
+        </p:txBody>
+      </p:sp>
+      <p:sp>
+        <p:nvSpPr>
+          <p:cNvPr id="23" name="TextBox 22"/>
+          <p:cNvSpPr txBox="1"/>
+          <p:nvPr/>
+        </p:nvSpPr>
+        <p:spPr>
+          <a:xfrm>
+            <a:off x="1517904" y="5788152"/>
+            <a:ext cx="2286000" cy="256032"/>
+          </a:xfrm>
+          <a:prstGeom prst="rect">
+            <a:avLst/>
+          </a:prstGeom>
+          <a:noFill/>
+        </p:spPr>
+        <p:txBody>
+          <a:bodyPr wrap="square" anchor="t" lIns="0" rIns="0" tIns="0" bIns="0">
+            <a:spAutoFit/>
+          </a:bodyPr>
+          <a:lstStyle/>
+          <a:p>
+            <a:pPr algn="l">
+              <a:lnSpc>
+                <a:spcPct val="125000"/>
+              </a:lnSpc>
+              <a:spcAft>
+                <a:spcPts val="0"/>
+              </a:spcAft>
+            </a:pPr>
+            <a:r>
+              <a:rPr sz="1100" b="0" i="0">
+                <a:solidFill>
+                  <a:srgbClr val="6B7C85"/>
+                </a:solidFill>
+                <a:latin typeface="Calibri"/>
+              </a:rPr>
+              <a:t>3 features</a:t>
+            </a:r>
+          </a:p>
+        </p:txBody>
+      </p:sp>
+      <p:sp>
+        <p:nvSpPr>
+          <p:cNvPr id="24" name="TextBox 23"/>
+          <p:cNvSpPr txBox="1"/>
+          <p:nvPr/>
+        </p:nvSpPr>
+        <p:spPr>
+          <a:xfrm>
+            <a:off x="4023360" y="5477256"/>
+            <a:ext cx="6949440" cy="566928"/>
+          </a:xfrm>
+          <a:prstGeom prst="rect">
+            <a:avLst/>
+          </a:prstGeom>
+          <a:noFill/>
+        </p:spPr>
+        <p:txBody>
+          <a:bodyPr wrap="square" anchor="t" lIns="0" rIns="0" tIns="0" bIns="0">
+            <a:spAutoFit/>
+          </a:bodyPr>
+          <a:lstStyle/>
+          <a:p>
+            <a:pPr algn="l">
+              <a:lnSpc>
+                <a:spcPct val="136000"/>
+              </a:lnSpc>
+              <a:spcAft>
+                <a:spcPts val="0"/>
+              </a:spcAft>
+            </a:pPr>
+            <a:r>
+              <a:rPr sz="1200" b="0" i="0">
+                <a:solidFill>
+                  <a:srgbClr val="0F2A35"/>
+                </a:solidFill>
+                <a:latin typeface="Calibri"/>
+              </a:rPr>
+              <a:t>Longitude, latitude and elevation, so the model can tell the Top End from the arid south without being handed the regions.</a:t>
+            </a:r>
+          </a:p>
+        </p:txBody>
+      </p:sp>
+      <p:sp>
+        <p:nvSpPr>
+          <p:cNvPr id="25" name="TextBox 24"/>
           <p:cNvSpPr txBox="1"/>
           <p:nvPr/>
         </p:nvSpPr>
@@ -19381,7 +19595,7 @@
       </p:sp>
       <p:sp>
         <p:nvSpPr>
-          <p:cNvPr id="21" name="TextBox 20"/>
+          <p:cNvPr id="26" name="TextBox 25"/>
           <p:cNvSpPr txBox="1"/>
           <p:nvPr/>
         </p:nvSpPr>
@@ -19423,7 +19637,7 @@
       </p:sp>
       <p:sp>
         <p:nvSpPr>
-          <p:cNvPr id="22" name="TextBox 21"/>
+          <p:cNvPr id="27" name="TextBox 26"/>
           <p:cNvSpPr txBox="1"/>
           <p:nvPr/>
         </p:nvSpPr>
@@ -19465,7 +19679,7 @@
       </p:sp>
       <p:sp>
         <p:nvSpPr>
-          <p:cNvPr id="23" name="TextBox 22"/>
+          <p:cNvPr id="28" name="TextBox 27"/>
           <p:cNvSpPr txBox="1"/>
           <p:nvPr/>
         </p:nvSpPr>

</xml_diff>